<commit_message>
docs: final deck says 'медиана < 0,1 с'; demo script matches UI (FU19 no было→стало, TO42 '27 м → 27000 мм')
</commit_message>
<xml_diff>
--- a/docs/presentation_final.pptx
+++ b/docs/presentation_final.pptx
@@ -684,7 +684,7 @@
           <a:p>
             <a:r>
               <a:rPr lang="en-US" dirty="0"/>
-              <a:t>Чем мы отличаемся. Первое — никаких нейросетей: решение строится на правилах и справочнике КТРУ, поэтому система ничего не выдумывает. Второе — работает полностью офлайн: SQLite-индекс и сервис на FastAPI, без внешних API; облачные LLM ТЗ всё равно запрещает. Третье — скорость: ответ быстрее десятой доли секунды, медиана 50–100 мс, пакет из 11 строк — около секунды. Четвёртое — объяснимость: у каждой характеристики бейдж источника, у каждого шага воронки — причина, у ошибки — подсказка с вариантом исправления. Пятое — порядок источников: сначала КТРУ, потом портал, и только если нигде нет — новая характеристика, на модерацию.</a:t>
+              <a:t>Чем мы отличаемся. Первое — никаких нейросетей: решение строится на правилах и справочнике КТРУ, поэтому система ничего не выдумывает. Второе — работает полностью офлайн: SQLite-индекс и сервис на FastAPI, без внешних API; облачные LLM ТЗ всё равно запрещает. Третье — скорость: медиана ответа меньше 0,1 секунды — 50–100 мс, пакет из 11 строк — около секунды. Четвёртое — объяснимость: у каждой характеристики бейдж источника, у каждого шага воронки — причина, у ошибки — подсказка с вариантом исправления. Пятое — порядок источников: сначала КТРУ, потом портал, и только если нигде нет — новая характеристика, на модерацию.</a:t>
             </a:r>
             <a:endParaRPr lang="en-US" dirty="0"/>
           </a:p>
@@ -4175,7 +4175,7 @@
                 <a:ea typeface="Open Sans" pitchFamily="34" charset="-122"/>
                 <a:cs typeface="Open Sans" pitchFamily="34" charset="-120"/>
               </a:rPr>
-              <a:t>Ответ &lt; 0,1 с</a:t>
+              <a:t>Медиана &lt; 0,1 с</a:t>
             </a:r>
             <a:endParaRPr lang="en-US" sz="1500" dirty="0"/>
           </a:p>
@@ -7537,7 +7537,7 @@
               <a:buNone/>
             </a:pPr>
             <a:r>
-              <a:rPr lang="en-US" sz="3000" b="1" dirty="0">
+              <a:rPr lang="en-US" sz="2600" b="1" dirty="0">
                 <a:solidFill>
                   <a:srgbClr val="DB2B21"/>
                 </a:solidFill>
@@ -7545,9 +7545,9 @@
                 <a:ea typeface="Open Sans" pitchFamily="34" charset="-122"/>
                 <a:cs typeface="Open Sans" pitchFamily="34" charset="-120"/>
               </a:rPr>
-              <a:t>&lt; 0,1 с</a:t>
-            </a:r>
-            <a:endParaRPr lang="en-US" sz="3000" dirty="0"/>
+              <a:t>медиана &lt; 0,1 с</a:t>
+            </a:r>
+            <a:endParaRPr lang="en-US" sz="2600" dirty="0"/>
           </a:p>
         </p:txBody>
       </p:sp>

</xml_diff>

<commit_message>
docs: final deck metrics update (funnel 1309 -> 3, 'сломай решение' 32/32, soft warnings 4/42)
</commit_message>
<xml_diff>
--- a/docs/presentation_final.pptx
+++ b/docs/presentation_final.pptx
@@ -596,7 +596,7 @@
           <a:p>
             <a:r>
               <a:rPr lang="en-US" dirty="0"/>
-              <a:t>Как это работает. Пользователь вводит свободный текст, например «Ключ гаечный 170 на 190 мм, длина 27 м», и нажимает «Проверить». Сервис разбирает строку на характеристики и по справочнику сужает коды КТРУ — здесь из 1514 кодов инструментов осталось 3. Дальше — карточка: код, таблица характеристик с бейджами источника, подсказки и блок «было → стало». Длина 27 метров подсвечена красным как ошибка, система предлагает 27 мм или 27 см. Любая правка сразу пересчитывает результат.</a:t>
+              <a:t>Как это работает. Пользователь вводит свободный текст, например «Ключ гаечный 170 на 190 мм, длина 27 м», и нажимает «Проверить». Сервис разбирает строку на характеристики и по справочнику сужает коды КТРУ — здесь из 1309 кодов инструментов осталось 3. Дальше — карточка: код, таблица характеристик с бейджами источника, подсказки и блок «было → стало». Длина 27 метров подсвечена красным как ошибка, система предлагает 27 мм или 27 см. Любая правка сразу пересчитывает результат.</a:t>
             </a:r>
             <a:endParaRPr lang="en-US" dirty="0"/>
           </a:p>
@@ -948,7 +948,7 @@
           <a:p>
             <a:r>
               <a:rPr lang="en-US" dirty="0"/>
-              <a:t>Качество мы мерили отдельно, эталоны зафиксированы до прогона. На основном наборе из 45 кейсов верный код КТРУ на первом месте в 44/45, в тройке — 45/45. На отложенном наборе из 45 новых позиций, под которые код не подстраивался, — 43/45 и 44/45. Ложные тревоги на чистых карточках — 1/42, и там в карточке настоящая ошибка: лобзик весом 2,1 грамма. Внесённые ошибки пойманы 30/30, но набор нам известен, так что оценка оптимистичная. Медиана ответа: основной набор 53–98 мс, отложенный 49–60 мс. Тест «сломай решение» — 28/32, без ответов 500 и ошибок JS. Источник: qa/metrics_slide.md (main 7aa9939).</a:t>
+              <a:t>Качество мы мерили отдельно, эталоны зафиксированы до прогона. На основном наборе из 45 кейсов верный код КТРУ на первом месте в 44/45, в тройке — 45/45. На отложенном наборе из 45 новых позиций, под которые код не подстраивался, — 43/45 и 44/45. Ложные тревоги на чистых карточках — 1/42, и там в карточке настоящая ошибка: лобзик весом 2,1 грамма. Внесённые ошибки пойманы 30/30, но набор нам известен, так что оценка оптимистичная. Медиана ответа: основной набор 53–98 мс, отложенный 49–60 мс. Тест «сломай решение» — 32/32, без ответов 500 и ошибок JS. Источник: qa/metrics_slide.md (main 7aa9939).</a:t>
             </a:r>
             <a:endParaRPr lang="en-US" dirty="0"/>
           </a:p>
@@ -3071,7 +3071,7 @@
                 <a:ea typeface="Open Sans" pitchFamily="34" charset="-122"/>
                 <a:cs typeface="Open Sans" pitchFamily="34" charset="-120"/>
               </a:rPr>
-              <a:t>Воронка 1514 → 3: домен, наименование, ОКПД2, характеристики — с причиной на каждом шаге</a:t>
+              <a:t>Воронка 1309 → 3: домен, наименование, ОКПД2, характеристики — с причиной на каждом шаге</a:t>
             </a:r>
             <a:endParaRPr lang="en-US" sz="1250" dirty="0"/>
           </a:p>
@@ -7698,7 +7698,7 @@
                 <a:ea typeface="Open Sans" pitchFamily="34" charset="-122"/>
                 <a:cs typeface="Open Sans" pitchFamily="34" charset="-120"/>
               </a:rPr>
-              <a:t>28/32</a:t>
+              <a:t>32/32</a:t>
             </a:r>
             <a:endParaRPr lang="en-US" sz="3000" dirty="0"/>
           </a:p>
@@ -7782,7 +7782,7 @@
                 <a:ea typeface="Open Sans" pitchFamily="34" charset="-122"/>
                 <a:cs typeface="Open Sans" pitchFamily="34" charset="-120"/>
               </a:rPr>
-              <a:t>88%: 0 ответов 500, 0 ошибок JS</a:t>
+              <a:t>100%: 0 ответов 500, 0 ошибок JS</a:t>
             </a:r>
             <a:endParaRPr lang="en-US" sz="1200" dirty="0"/>
           </a:p>
@@ -7824,7 +7824,7 @@
                 <a:ea typeface="Open Sans" pitchFamily="34" charset="-122"/>
                 <a:cs typeface="Open Sans" pitchFamily="34" charset="-120"/>
               </a:rPr>
-              <a:t>* оценка оптимистичная, набор известен разработчикам. Статус верный: 45/45 и 43/45; мягкие предупреждения на чистых — 3/42.</a:t>
+              <a:t>* оценка оптимистичная, набор известен разработчикам. Статус верный: 45/45 и 43/45; мягкие предупреждения на чистых — 4/42.</a:t>
             </a:r>
             <a:endParaRPr lang="en-US" sz="1150" dirty="0"/>
           </a:p>

</xml_diff>

<commit_message>
docs: final deck uses retaken screenshots (slide 2 funnel 1309 -> 3 crop, slide 5 fill block + 13-row batch); batch numbers in metrics.js
</commit_message>
<xml_diff>
--- a/docs/presentation_final.pptx
+++ b/docs/presentation_final.pptx
@@ -684,7 +684,7 @@
           <a:p>
             <a:r>
               <a:rPr lang="en-US" dirty="0"/>
-              <a:t>Чем мы отличаемся. Первое — никаких нейросетей: решение строится на правилах и справочнике КТРУ, поэтому система ничего не выдумывает. Второе — работает полностью офлайн: SQLite-индекс и сервис на FastAPI, без внешних API; облачные LLM ТЗ всё равно запрещает. Третье — скорость: медиана ответа меньше 0,1 секунды — 50–100 мс, пакет из 11 строк — около секунды. Четвёртое — объяснимость: у каждой характеристики бейдж источника, у каждого шага воронки — причина, у ошибки — подсказка с вариантом исправления. Пятое — порядок источников: сначала КТРУ, потом портал, и только если нигде нет — новая характеристика, на модерацию.</a:t>
+              <a:t>Чем мы отличаемся. Первое — никаких нейросетей: решение строится на правилах и справочнике КТРУ, поэтому система ничего не выдумывает. Второе — работает полностью офлайн: SQLite-индекс и сервис на FastAPI, без внешних API; облачные LLM ТЗ всё равно запрещает. Третье — скорость: медиана ответа меньше 0,1 секунды — 50–100 мс, пакет из 13 строк — около 1,3 секунды. Четвёртое — объяснимость: у каждой характеристики бейдж источника, у каждого шага воронки — причина, у ошибки — подсказка с вариантом исправления. Пятое — порядок источников: сначала КТРУ, потом портал, и только если нигде нет — новая характеристика, на модерацию.</a:t>
             </a:r>
             <a:endParaRPr lang="en-US" dirty="0"/>
           </a:p>
@@ -860,7 +860,7 @@
           <a:p>
             <a:r>
               <a:rPr lang="en-US" dirty="0"/>
-              <a:t>Как заполняется карточка. Приоритет: если характеристика есть в спецификации кода — бейдж «КТРУ»; если нет — ищем среди характеристик портала; если и там нет — «Новая», она уходит на модерацию. Блок «Допишите» показывает, сколько осталось, и даёт допустимые значения КТРУ чипами: заполнить можно в один клик. Для массовой загрузки есть пакетная проверка: CSV со столбцом наименований, каждая строка проверяется как одиночный товар. Наш демо-файл из 11 строк — около секунды: 8 кодов определены, 2 неоднозначны, 1 не найден. Щелчок по строке открывает её в редакторе, результат выгружается в CSV.</a:t>
+              <a:t>Как заполняется карточка. Приоритет: если характеристика есть в спецификации кода — бейдж «КТРУ»; если нет — ищем среди характеристик портала; если и там нет — «Новая», она уходит на модерацию. Блок «Допишите» показывает, сколько осталось, и даёт допустимые значения КТРУ чипами: заполнить можно в один клик. Для массовой загрузки есть пакетная проверка: CSV со столбцом наименований, каждая строка проверяется как одиночный товар. Наш демо-файл из 13 строк — около 1,3 секунды: 9 кодов определены, 2 неоднозначны, 2 строки — не наша категория. Щелчок по строке открывает её в редакторе, результат выгружается в CSV.</a:t>
             </a:r>
             <a:endParaRPr lang="en-US" dirty="0"/>
           </a:p>
@@ -3267,13 +3267,59 @@
         </p:nvPicPr>
         <p:blipFill>
           <a:blip r:embed="rId1"/>
-          <a:srcRect l="0" r="0" t="0" b="57256"/>
+          <a:srcRect l="0" r="0" t="0" b="77467"/>
           <a:stretch/>
         </p:blipFill>
         <p:spPr>
           <a:xfrm>
             <a:off x="5623560" y="1828800"/>
-            <a:ext cx="5696712" cy="4105656"/>
+            <a:ext cx="5696712" cy="2359152"/>
+          </a:xfrm>
+          <a:prstGeom prst="rect">
+            <a:avLst/>
+          </a:prstGeom>
+        </p:spPr>
+      </p:pic>
+      <p:sp>
+        <p:nvSpPr>
+          <p:cNvPr id="29" name="Shape 26"/>
+          <p:cNvSpPr/>
+          <p:nvPr/>
+        </p:nvSpPr>
+        <p:spPr>
+          <a:xfrm>
+            <a:off x="5623560" y="4251960"/>
+            <a:ext cx="5696712" cy="0"/>
+          </a:xfrm>
+          <a:prstGeom prst="line">
+            <a:avLst/>
+          </a:prstGeom>
+          <a:noFill/>
+          <a:ln w="12700">
+            <a:solidFill>
+              <a:srgbClr val="C5D3E6"/>
+            </a:solidFill>
+            <a:prstDash val="solid"/>
+          </a:ln>
+        </p:spPr>
+      </p:sp>
+      <p:pic>
+        <p:nvPicPr>
+          <p:cNvPr id="30" name="Image 1" descr="/workspace/slides/tenderhack-final-uybj3a/src/screens/main_result.png">    </p:cNvPr>
+          <p:cNvPicPr>
+            <a:picLocks noChangeAspect="1"/>
+          </p:cNvPicPr>
+          <p:nvPr/>
+        </p:nvPicPr>
+        <p:blipFill>
+          <a:blip r:embed="rId2"/>
+          <a:srcRect l="36491" r="5965" t="67774" b="23180"/>
+          <a:stretch/>
+        </p:blipFill>
+        <p:spPr>
+          <a:xfrm>
+            <a:off x="5623560" y="4315968"/>
+            <a:ext cx="5696712" cy="1645920"/>
           </a:xfrm>
           <a:prstGeom prst="rect">
             <a:avLst/>
@@ -4217,7 +4263,7 @@
                 <a:ea typeface="Open Sans" pitchFamily="34" charset="-122"/>
                 <a:cs typeface="Open Sans" pitchFamily="34" charset="-120"/>
               </a:rPr>
-              <a:t>Медиана 50–100 мс на запрос; пакет из 11 строк — ≈1 с</a:t>
+              <a:t>Медиана 50–100 мс на запрос; пакет из 13 строк — ≈1,3 с</a:t>
             </a:r>
             <a:endParaRPr lang="en-US" sz="1200" dirty="0"/>
           </a:p>
@@ -6245,8 +6291,8 @@
         </p:blipFill>
         <p:spPr>
           <a:xfrm>
-            <a:off x="1442302" y="3721608"/>
-            <a:ext cx="3927675" cy="2176272"/>
+            <a:off x="1336898" y="3721608"/>
+            <a:ext cx="4138484" cy="2176272"/>
           </a:xfrm>
           <a:prstGeom prst="rect">
             <a:avLst/>
@@ -6313,7 +6359,7 @@
                 <a:ea typeface="Open Sans" pitchFamily="34" charset="-122"/>
                 <a:cs typeface="Open Sans" pitchFamily="34" charset="-120"/>
               </a:rPr>
-              <a:t>Пакетная проверка (CSV): 11 строк ≈ 1 с</a:t>
+              <a:t>Пакетная проверка (CSV): 13 строк ≈ 1,3 с</a:t>
             </a:r>
             <a:endParaRPr lang="en-US" sz="1300" dirty="0"/>
           </a:p>
@@ -6329,7 +6375,7 @@
         </p:nvPicPr>
         <p:blipFill>
           <a:blip r:embed="rId2"/>
-          <a:srcRect l="0" r="0" t="24318" b="14033"/>
+          <a:srcRect l="0" r="0" t="27915" b="22063"/>
           <a:stretch/>
         </p:blipFill>
         <p:spPr>
@@ -6389,7 +6435,7 @@
                 <a:ea typeface="Open Sans" pitchFamily="34" charset="-122"/>
                 <a:cs typeface="Open Sans" pitchFamily="34" charset="-120"/>
               </a:rPr>
-              <a:t>8 определён · 2 неоднозначно · 1 не найден</a:t>
+              <a:t>9 определён · 2 неоднозначно · 2 не наша категория</a:t>
             </a:r>
             <a:endParaRPr lang="en-US" sz="1200" dirty="0"/>
           </a:p>
@@ -6420,7 +6466,7 @@
                 <a:ea typeface="Open Sans" pitchFamily="34" charset="-122"/>
                 <a:cs typeface="Open Sans" pitchFamily="34" charset="-120"/>
               </a:rPr>
-              <a:t>4 заполнена · 6 неполная · 1 с ошибками</a:t>
+              <a:t>4 заполнена · 8 неполная · 1 с ошибками</a:t>
             </a:r>
             <a:endParaRPr lang="en-US" sz="1200" dirty="0"/>
           </a:p>

</xml_diff>

<commit_message>
docs: final deck batch 13 rows ~0,5 s, build label main ab39ee1, KTRU 3030 positions
</commit_message>
<xml_diff>
--- a/docs/presentation_final.pptx
+++ b/docs/presentation_final.pptx
@@ -684,7 +684,7 @@
           <a:p>
             <a:r>
               <a:rPr lang="en-US" dirty="0"/>
-              <a:t>Чем мы отличаемся. Первое — никаких нейросетей: решение строится на правилах и справочнике КТРУ, поэтому система ничего не выдумывает. Второе — работает полностью офлайн: SQLite-индекс и сервис на FastAPI, без внешних API; облачные LLM ТЗ всё равно запрещает. Третье — скорость: медиана ответа меньше 0,1 секунды — 50–100 мс, пакет из 13 строк — около 1,3 секунды. Четвёртое — объяснимость: у каждой характеристики бейдж источника, у каждого шага воронки — причина, у ошибки — подсказка с вариантом исправления. Пятое — порядок источников: сначала КТРУ, потом портал, и только если нигде нет — новая характеристика, на модерацию.</a:t>
+              <a:t>Чем мы отличаемся. Первое — никаких нейросетей: решение строится на правилах и справочнике КТРУ, поэтому система ничего не выдумывает. Второе — работает полностью офлайн: SQLite-индекс и сервис на FastAPI, без внешних API; облачные LLM ТЗ всё равно запрещает. Третье — скорость: медиана ответа меньше 0,1 секунды — 50–100 мс, пакет из 13 строк — около 0,5 секунды. Четвёртое — объяснимость: у каждой характеристики бейдж источника, у каждого шага воронки — причина, у ошибки — подсказка с вариантом исправления. Пятое — порядок источников: сначала КТРУ, потом портал, и только если нигде нет — новая характеристика, на модерацию.</a:t>
             </a:r>
             <a:endParaRPr lang="en-US" dirty="0"/>
           </a:p>
@@ -860,7 +860,7 @@
           <a:p>
             <a:r>
               <a:rPr lang="en-US" dirty="0"/>
-              <a:t>Как заполняется карточка. Приоритет: если характеристика есть в спецификации кода — бейдж «КТРУ»; если нет — ищем среди характеристик портала; если и там нет — «Новая», она уходит на модерацию. Блок «Допишите» показывает, сколько осталось, и даёт допустимые значения КТРУ чипами: заполнить можно в один клик. Для массовой загрузки есть пакетная проверка: CSV со столбцом наименований, каждая строка проверяется как одиночный товар. Наш демо-файл из 13 строк — около 1,3 секунды: 9 кодов определены, 2 неоднозначны, 2 строки — не наша категория. Щелчок по строке открывает её в редакторе, результат выгружается в CSV.</a:t>
+              <a:t>Как заполняется карточка. Приоритет: если характеристика есть в спецификации кода — бейдж «КТРУ»; если нет — ищем среди характеристик портала; если и там нет — «Новая», она уходит на модерацию. Блок «Допишите» показывает, сколько осталось, и даёт допустимые значения КТРУ чипами: заполнить можно в один клик. Для массовой загрузки есть пакетная проверка: CSV со столбцом наименований, каждая строка проверяется как одиночный товар. Наш демо-файл из 13 строк — около 0,5 секунды: 9 кодов определены, 2 неоднозначны, 2 строки — не наша категория. Щелчок по строке открывает её в редакторе, результат выгружается в CSV.</a:t>
             </a:r>
             <a:endParaRPr lang="en-US" dirty="0"/>
           </a:p>
@@ -948,7 +948,7 @@
           <a:p>
             <a:r>
               <a:rPr lang="en-US" dirty="0"/>
-              <a:t>Качество мы мерили отдельно, эталоны зафиксированы до прогона. На основном наборе из 45 кейсов верный код КТРУ на первом месте в 44/45, в тройке — 45/45. На отложенном наборе из 45 новых позиций, под которые код не подстраивался, — 43/45 и 44/45. Ложные тревоги на чистых карточках — 1/42, и там в карточке настоящая ошибка: лобзик весом 2,1 грамма. Внесённые ошибки пойманы 30/30, но набор нам известен, так что оценка оптимистичная. Медиана ответа: основной набор 53–98 мс, отложенный 49–60 мс. Тест «сломай решение» — 32/32, без ответов 500 и ошибок JS. Источник: qa/metrics_slide.md (main 7aa9939).</a:t>
+              <a:t>Качество мы мерили отдельно, эталоны зафиксированы до прогона. На основном наборе из 45 кейсов верный код КТРУ на первом месте в 44/45, в тройке — 45/45. На отложенном наборе из 45 новых позиций, под которые код не подстраивался, — 43/45 и 44/45. Ложные тревоги на чистых карточках — 1/42, и там в карточке настоящая ошибка: лобзик весом 2,1 грамма. Внесённые ошибки пойманы 30/30, но набор нам известен, так что оценка оптимистичная. Медиана ответа: основной набор 53–98 мс, отложенный 49–60 мс. Тест «сломай решение» — 32/32, без ответов 500 и ошибок JS. Источник: qa/metrics_slide.md.</a:t>
             </a:r>
             <a:endParaRPr lang="en-US" dirty="0"/>
           </a:p>
@@ -4263,7 +4263,7 @@
                 <a:ea typeface="Open Sans" pitchFamily="34" charset="-122"/>
                 <a:cs typeface="Open Sans" pitchFamily="34" charset="-120"/>
               </a:rPr>
-              <a:t>Медиана 50–100 мс на запрос; пакет из 13 строк — ≈1,3 с</a:t>
+              <a:t>Медиана 50–100 мс на запрос; пакет из 13 строк — ~0,5 с</a:t>
             </a:r>
             <a:endParaRPr lang="en-US" sz="1200" dirty="0"/>
           </a:p>
@@ -6359,7 +6359,7 @@
                 <a:ea typeface="Open Sans" pitchFamily="34" charset="-122"/>
                 <a:cs typeface="Open Sans" pitchFamily="34" charset="-120"/>
               </a:rPr>
-              <a:t>Пакетная проверка (CSV): 13 строк ≈ 1,3 с</a:t>
+              <a:t>Пакетная проверка (CSV): 13 строк за ~0,5 с</a:t>
             </a:r>
             <a:endParaRPr lang="en-US" sz="1300" dirty="0"/>
           </a:p>
@@ -6910,7 +6910,7 @@
                 <a:ea typeface="Open Sans" pitchFamily="34" charset="-122"/>
                 <a:cs typeface="Open Sans" pitchFamily="34" charset="-120"/>
               </a:rPr>
-              <a:t>Эталоны зафиксированы до прогона · два набора по 45 позиций · источник: qa/metrics_slide.md (main 7aa9939)</a:t>
+              <a:t>Цифры на текущей версии · Версия: main ab39ee1 · эталоны зафиксированы до прогона · qa/metrics_slide.md</a:t>
             </a:r>
             <a:endParaRPr lang="en-US" sz="1300" dirty="0"/>
           </a:p>

</xml_diff>

<commit_message>
docs: deck plural for KTRU positions, final deck regenerated (slide 6 p50 51-54 / 48-54 ms)
</commit_message>
<xml_diff>
--- a/docs/presentation_final.pptx
+++ b/docs/presentation_final.pptx
@@ -4,9 +4,6 @@
   <p:sldMasterIdLst>
     <p:sldMasterId id="2147483648" r:id="rId1"/>
   </p:sldMasterIdLst>
-  <p:notesMasterIdLst>
-    <p:notesMasterId r:id="rId9"/>
-  </p:notesMasterIdLst>
   <p:sldIdLst>
     <p:sldId id="256" r:id="rId2"/>
     <p:sldId id="257" r:id="rId3"/>
@@ -16,6 +13,9 @@
     <p:sldId id="261" r:id="rId7"/>
     <p:sldId id="262" r:id="rId8"/>
   </p:sldIdLst>
+  <p:notesMasterIdLst>
+    <p:notesMasterId r:id="rId9"/>
+  </p:notesMasterIdLst>
   <p:sldSz cx="12192000" cy="6858000"/>
   <p:notesSz cx="6858000" cy="12192000"/>
   <p:defaultTextStyle>
@@ -948,7 +948,7 @@
           <a:p>
             <a:r>
               <a:rPr lang="en-US" dirty="0"/>
-              <a:t>Качество мы мерили отдельно, эталоны зафиксированы до прогона. На основном наборе из 45 кейсов верный код КТРУ на первом месте в 44/45, в тройке — 45/45. На отложенном наборе из 45 новых позиций, под которые код не подстраивался, — 43/45 и 44/45. Ложные тревоги на чистых карточках — 1/42, и там в карточке настоящая ошибка: лобзик весом 2,1 грамма. Внесённые ошибки пойманы 30/30, но набор нам известен, так что оценка оптимистичная. Медиана ответа: основной набор 53–98 мс, отложенный 49–60 мс. Тест «сломай решение» — 32/32, без ответов 500 и ошибок JS. Источник: qa/metrics_slide.md.</a:t>
+              <a:t>Качество мы мерили отдельно, эталоны зафиксированы до прогона. На основном наборе из 45 кейсов верный код КТРУ на первом месте в 44/45, в тройке — 45/45. На отложенном наборе из 45 новых позиций, под которые код не подстраивался, — 43/45 и 44/45. Ложные тревоги на чистых карточках — 1/42, и там в карточке настоящая ошибка: лобзик весом 2,1 грамма. Внесённые ошибки пойманы 30/30, но набор нам известен, так что оценка оптимистичная. Медиана ответа: основной набор 51–54 мс, отложенный 48–54 мс. Тест «сломай решение» — 32/32, без ответов 500 и ошибок JS. Источник: qa/metrics_slide.md.</a:t>
             </a:r>
             <a:endParaRPr lang="en-US" dirty="0"/>
           </a:p>
@@ -3259,7 +3259,7 @@
       </p:sp>
       <p:pic>
         <p:nvPicPr>
-          <p:cNvPr id="28" name="Image 0" descr="/workspace/slides/tenderhack-final-uybj3a/src/screens/main_result.png">    </p:cNvPr>
+          <p:cNvPr id="28" name="Image 0" descr="/workspace/deckbuild/r/docs/screens/main_result.png">    </p:cNvPr>
           <p:cNvPicPr>
             <a:picLocks noChangeAspect="1"/>
           </p:cNvPicPr>
@@ -3305,7 +3305,7 @@
       </p:sp>
       <p:pic>
         <p:nvPicPr>
-          <p:cNvPr id="30" name="Image 1" descr="/workspace/slides/tenderhack-final-uybj3a/src/screens/main_result.png">    </p:cNvPr>
+          <p:cNvPr id="30" name="Image 1" descr="/workspace/deckbuild/r/docs/screens/main_result.png">    </p:cNvPr>
           <p:cNvPicPr>
             <a:picLocks noChangeAspect="1"/>
           </p:cNvPicPr>
@@ -5126,7 +5126,7 @@
       </p:sp>
       <p:pic>
         <p:nvPicPr>
-          <p:cNvPr id="17" name="Image 0" descr="/workspace/slides/tenderhack-final-uybj3a/src/process.png">    </p:cNvPr>
+          <p:cNvPr id="17" name="Image 0" descr="/workspace/deckbuild/r/docs/process.png">    </p:cNvPr>
           <p:cNvPicPr>
             <a:picLocks noChangeAspect="1"/>
           </p:cNvPicPr>
@@ -5284,7 +5284,7 @@
       </p:sp>
       <p:pic>
         <p:nvPicPr>
-          <p:cNvPr id="21" name="Image 1" descr="/workspace/slides/tenderhack-final-uybj3a/src/components.png">    </p:cNvPr>
+          <p:cNvPr id="21" name="Image 1" descr="/workspace/deckbuild/r/docs/components.png">    </p:cNvPr>
           <p:cNvPicPr>
             <a:picLocks noChangeAspect="1"/>
           </p:cNvPicPr>
@@ -6277,7 +6277,7 @@
       </p:sp>
       <p:pic>
         <p:nvPicPr>
-          <p:cNvPr id="30" name="Image 0" descr="/workspace/slides/tenderhack-final-uybj3a/src/screens/fill_block.png">    </p:cNvPr>
+          <p:cNvPr id="30" name="Image 0" descr="/workspace/deckbuild/r/docs/screens/fill_block.png">    </p:cNvPr>
           <p:cNvPicPr>
             <a:picLocks noChangeAspect="1"/>
           </p:cNvPicPr>
@@ -6367,7 +6367,7 @@
       </p:sp>
       <p:pic>
         <p:nvPicPr>
-          <p:cNvPr id="33" name="Image 1" descr="/workspace/slides/tenderhack-final-uybj3a/src/screens/batch_view.png">    </p:cNvPr>
+          <p:cNvPr id="33" name="Image 1" descr="/workspace/deckbuild/r/docs/screens/batch_view.png">    </p:cNvPr>
           <p:cNvPicPr>
             <a:picLocks noChangeAspect="1"/>
           </p:cNvPicPr>
@@ -6426,20 +6426,6 @@
               </a:rPr>
               <a:t>Код: </a:t>
             </a:r>
-            <a:r>
-              <a:rPr lang="en-US" sz="1200" dirty="0">
-                <a:solidFill>
-                  <a:srgbClr val="1A1A1A"/>
-                </a:solidFill>
-                <a:latin typeface="Open Sans" pitchFamily="34" charset="0"/>
-                <a:ea typeface="Open Sans" pitchFamily="34" charset="-122"/>
-                <a:cs typeface="Open Sans" pitchFamily="34" charset="-120"/>
-              </a:rPr>
-              <a:t>9 определён · 2 неоднозначно · 2 не наша категория</a:t>
-            </a:r>
-            <a:endParaRPr lang="en-US" sz="1200" dirty="0"/>
-          </a:p>
-          <a:p>
             <a:pPr indent="0" marL="0">
               <a:lnSpc>
                 <a:spcPct val="115000"/>
@@ -6447,6 +6433,26 @@
               <a:buNone/>
             </a:pPr>
             <a:r>
+              <a:rPr lang="en-US" sz="1200" dirty="0">
+                <a:solidFill>
+                  <a:srgbClr val="1A1A1A"/>
+                </a:solidFill>
+                <a:latin typeface="Open Sans" pitchFamily="34" charset="0"/>
+                <a:ea typeface="Open Sans" pitchFamily="34" charset="-122"/>
+                <a:cs typeface="Open Sans" pitchFamily="34" charset="-120"/>
+              </a:rPr>
+              <a:t>9 определён · 2 неоднозначно · 2 не наша категория</a:t>
+            </a:r>
+            <a:endParaRPr lang="en-US" sz="1200" dirty="0"/>
+          </a:p>
+          <a:p>
+            <a:pPr indent="0" marL="0">
+              <a:lnSpc>
+                <a:spcPct val="115000"/>
+              </a:lnSpc>
+              <a:buNone/>
+            </a:pPr>
+            <a:r>
               <a:rPr lang="en-US" sz="1200" b="1" dirty="0">
                 <a:solidFill>
                   <a:srgbClr val="1A1A1A"/>
@@ -6457,6 +6463,12 @@
               </a:rPr>
               <a:t>Карточка: </a:t>
             </a:r>
+            <a:pPr indent="0" marL="0">
+              <a:lnSpc>
+                <a:spcPct val="115000"/>
+              </a:lnSpc>
+              <a:buNone/>
+            </a:pPr>
             <a:r>
               <a:rPr lang="en-US" sz="1200" dirty="0">
                 <a:solidFill>
@@ -7675,7 +7687,7 @@
                 <a:ea typeface="Open Sans" pitchFamily="34" charset="-122"/>
                 <a:cs typeface="Open Sans" pitchFamily="34" charset="-120"/>
               </a:rPr>
-              <a:t>основной 53–98 мс, отложенный 49–60 мс</a:t>
+              <a:t>основной 51–54, отложенный 48–54 мс</a:t>
             </a:r>
             <a:endParaRPr lang="en-US" sz="1200" dirty="0"/>
           </a:p>

</xml_diff>